<commit_message>
Add 3 critical questions to Gate2 presentation + create summary deck
- Gate2-Presentation.pptx: Add slide 5 with 3 Priority Tier 1 discovery questions
- Apex-Summary-Presentation.pptx: New high-level summary deck (8 slides)
- Supporting scripts: add_questions_slide.py, build_summary_pptx.py

Questions added:
Q1: Driver App API surface (GPS vs message-only)
Q2: CRM status freshness (real-time vs batch)
Q3: Sandra credit audit gap (compliance risk)

Co-Authored-By: Claude Opus 4.7 <noreply@anthropic.com>
</commit_message>
<xml_diff>
--- a/FDE-assessment-week2/Gate2-Presentation.pptx
+++ b/FDE-assessment-week2/Gate2-Presentation.pptx
@@ -9,8 +9,9 @@
     <p:sldId id="257" r:id="rId8"/>
     <p:sldId id="258" r:id="rId9"/>
     <p:sldId id="259" r:id="rId10"/>
+    <p:sldId id="261" r:id="rId12"/>
     <p:sldId id="260" r:id="rId11"/>
-    <p:sldId id="261" r:id="rId12"/>
+    <p:sldId id="262" r:id="rId13"/>
   </p:sldIdLst>
   <p:sldSz cx="12188952" cy="6858000" type="screen4x3"/>
   <p:notesSz cx="6858000" cy="9144000"/>
@@ -11369,6 +11370,604 @@
           </a:p>
         </p:txBody>
       </p:sp>
+      <p:sp>
+        <p:nvSpPr>
+          <p:cNvPr id="55" name="Rectangle 54"/>
+          <p:cNvSpPr/>
+          <p:nvPr/>
+        </p:nvSpPr>
+        <p:spPr>
+          <a:xfrm>
+            <a:off x="0" y="0"/>
+            <a:ext cx="12188952" cy="914400"/>
+          </a:xfrm>
+          <a:prstGeom prst="rect">
+            <a:avLst/>
+          </a:prstGeom>
+          <a:solidFill>
+            <a:srgbClr val="1B3A6B"/>
+          </a:solidFill>
+          <a:ln>
+            <a:noFill/>
+          </a:ln>
+        </p:spPr>
+        <p:style>
+          <a:lnRef idx="1">
+            <a:schemeClr val="accent1"/>
+          </a:lnRef>
+          <a:fillRef idx="3">
+            <a:schemeClr val="accent1"/>
+          </a:fillRef>
+          <a:effectRef idx="2">
+            <a:schemeClr val="accent1"/>
+          </a:effectRef>
+          <a:fontRef idx="minor">
+            <a:schemeClr val="lt1"/>
+          </a:fontRef>
+        </p:style>
+        <p:txBody>
+          <a:bodyPr rtlCol="0" anchor="ctr"/>
+          <a:lstStyle/>
+          <a:p>
+            <a:pPr algn="ctr"/>
+          </a:p>
+        </p:txBody>
+      </p:sp>
+      <p:sp>
+        <p:nvSpPr>
+          <p:cNvPr id="56" name="TextBox 55"/>
+          <p:cNvSpPr txBox="1"/>
+          <p:nvPr/>
+        </p:nvSpPr>
+        <p:spPr>
+          <a:xfrm>
+            <a:off x="457200" y="274320"/>
+            <a:ext cx="10972800" cy="457200"/>
+          </a:xfrm>
+          <a:prstGeom prst="rect">
+            <a:avLst/>
+          </a:prstGeom>
+          <a:noFill/>
+        </p:spPr>
+        <p:txBody>
+          <a:bodyPr wrap="square">
+            <a:spAutoFit/>
+          </a:bodyPr>
+          <a:lstStyle/>
+          <a:p>
+            <a:pPr algn="l"/>
+            <a:r>
+              <a:rPr sz="3200" b="1" i="0">
+                <a:solidFill>
+                  <a:srgbClr val="FFFFFF"/>
+                </a:solidFill>
+              </a:rPr>
+              <a:t>3 Critical Questions for Sarah</a:t>
+            </a:r>
+          </a:p>
+        </p:txBody>
+      </p:sp>
+      <p:sp>
+        <p:nvSpPr>
+          <p:cNvPr id="57" name="TextBox 56"/>
+          <p:cNvSpPr txBox="1"/>
+          <p:nvPr/>
+        </p:nvSpPr>
+        <p:spPr>
+          <a:xfrm>
+            <a:off x="457200" y="1097280"/>
+            <a:ext cx="10972800" cy="274320"/>
+          </a:xfrm>
+          <a:prstGeom prst="rect">
+            <a:avLst/>
+          </a:prstGeom>
+          <a:noFill/>
+        </p:spPr>
+        <p:txBody>
+          <a:bodyPr wrap="square">
+            <a:spAutoFit/>
+          </a:bodyPr>
+          <a:lstStyle/>
+          <a:p>
+            <a:pPr algn="ctr"/>
+            <a:r>
+              <a:rPr sz="1600" b="0" i="1">
+                <a:solidFill>
+                  <a:srgbClr val="606060"/>
+                </a:solidFill>
+              </a:rPr>
+              <a:t>Answers will materially change the agent design</a:t>
+            </a:r>
+          </a:p>
+        </p:txBody>
+      </p:sp>
+      <p:sp>
+        <p:nvSpPr>
+          <p:cNvPr id="58" name="Rectangle 57"/>
+          <p:cNvSpPr/>
+          <p:nvPr/>
+        </p:nvSpPr>
+        <p:spPr>
+          <a:xfrm>
+            <a:off x="457200" y="1645920"/>
+            <a:ext cx="11247120" cy="1280160"/>
+          </a:xfrm>
+          <a:prstGeom prst="rect">
+            <a:avLst/>
+          </a:prstGeom>
+          <a:solidFill>
+            <a:srgbClr val="F2F4F7"/>
+          </a:solidFill>
+          <a:ln>
+            <a:noFill/>
+          </a:ln>
+        </p:spPr>
+        <p:style>
+          <a:lnRef idx="1">
+            <a:schemeClr val="accent1"/>
+          </a:lnRef>
+          <a:fillRef idx="3">
+            <a:schemeClr val="accent1"/>
+          </a:fillRef>
+          <a:effectRef idx="2">
+            <a:schemeClr val="accent1"/>
+          </a:effectRef>
+          <a:fontRef idx="minor">
+            <a:schemeClr val="lt1"/>
+          </a:fontRef>
+        </p:style>
+        <p:txBody>
+          <a:bodyPr rtlCol="0" anchor="ctr"/>
+          <a:lstStyle/>
+          <a:p>
+            <a:pPr algn="ctr"/>
+          </a:p>
+        </p:txBody>
+      </p:sp>
+      <p:sp>
+        <p:nvSpPr>
+          <p:cNvPr id="59" name="TextBox 58"/>
+          <p:cNvSpPr txBox="1"/>
+          <p:nvPr/>
+        </p:nvSpPr>
+        <p:spPr>
+          <a:xfrm>
+            <a:off x="640080" y="1828800"/>
+            <a:ext cx="10789920" cy="274320"/>
+          </a:xfrm>
+          <a:prstGeom prst="rect">
+            <a:avLst/>
+          </a:prstGeom>
+          <a:noFill/>
+        </p:spPr>
+        <p:txBody>
+          <a:bodyPr wrap="square">
+            <a:spAutoFit/>
+          </a:bodyPr>
+          <a:lstStyle/>
+          <a:p>
+            <a:pPr algn="l"/>
+            <a:r>
+              <a:rPr sz="1600" b="1" i="0">
+                <a:solidFill>
+                  <a:srgbClr val="1B3A6B"/>
+                </a:solidFill>
+              </a:rPr>
+              <a:t>Q1: Driver App API — GPS Query or Message-Only?</a:t>
+            </a:r>
+          </a:p>
+        </p:txBody>
+      </p:sp>
+      <p:sp>
+        <p:nvSpPr>
+          <p:cNvPr id="60" name="TextBox 59"/>
+          <p:cNvSpPr txBox="1"/>
+          <p:nvPr/>
+        </p:nvSpPr>
+        <p:spPr>
+          <a:xfrm>
+            <a:off x="640080" y="2194560"/>
+            <a:ext cx="10789920" cy="457200"/>
+          </a:xfrm>
+          <a:prstGeom prst="rect">
+            <a:avLst/>
+          </a:prstGeom>
+          <a:noFill/>
+        </p:spPr>
+        <p:txBody>
+          <a:bodyPr wrap="square">
+            <a:spAutoFit/>
+          </a:bodyPr>
+          <a:lstStyle/>
+          <a:p>
+            <a:pPr algn="l"/>
+            <a:r>
+              <a:rPr sz="1300" b="0" i="0">
+                <a:solidFill>
+                  <a:srgbClr val="2D2D2D"/>
+                </a:solidFill>
+              </a:rPr>
+              <a:t>Can the agent programmatically query driver GPS for real-time location, or must it send a message and wait for driver reply?</a:t>
+            </a:r>
+          </a:p>
+        </p:txBody>
+      </p:sp>
+      <p:sp>
+        <p:nvSpPr>
+          <p:cNvPr id="61" name="TextBox 60"/>
+          <p:cNvSpPr txBox="1"/>
+          <p:nvPr/>
+        </p:nvSpPr>
+        <p:spPr>
+          <a:xfrm>
+            <a:off x="640080" y="2560320"/>
+            <a:ext cx="10789920" cy="365760"/>
+          </a:xfrm>
+          <a:prstGeom prst="rect">
+            <a:avLst/>
+          </a:prstGeom>
+          <a:noFill/>
+        </p:spPr>
+        <p:txBody>
+          <a:bodyPr wrap="square">
+            <a:spAutoFit/>
+          </a:bodyPr>
+          <a:lstStyle/>
+          <a:p>
+            <a:pPr algn="l"/>
+            <a:r>
+              <a:rPr sz="1200" b="0" i="1">
+                <a:solidFill>
+                  <a:srgbClr val="BF352A"/>
+                </a:solidFill>
+              </a:rPr>
+              <a:t>Impact: If message-only, ETA response time has a 2-min floor. If no API, agent becomes lookup-only tool.</a:t>
+            </a:r>
+          </a:p>
+        </p:txBody>
+      </p:sp>
+      <p:sp>
+        <p:nvSpPr>
+          <p:cNvPr id="62" name="Rectangle 61"/>
+          <p:cNvSpPr/>
+          <p:nvPr/>
+        </p:nvSpPr>
+        <p:spPr>
+          <a:xfrm>
+            <a:off x="457200" y="3108960"/>
+            <a:ext cx="11247120" cy="1280160"/>
+          </a:xfrm>
+          <a:prstGeom prst="rect">
+            <a:avLst/>
+          </a:prstGeom>
+          <a:solidFill>
+            <a:srgbClr val="F2F4F7"/>
+          </a:solidFill>
+          <a:ln>
+            <a:noFill/>
+          </a:ln>
+        </p:spPr>
+        <p:style>
+          <a:lnRef idx="1">
+            <a:schemeClr val="accent1"/>
+          </a:lnRef>
+          <a:fillRef idx="3">
+            <a:schemeClr val="accent1"/>
+          </a:fillRef>
+          <a:effectRef idx="2">
+            <a:schemeClr val="accent1"/>
+          </a:effectRef>
+          <a:fontRef idx="minor">
+            <a:schemeClr val="lt1"/>
+          </a:fontRef>
+        </p:style>
+        <p:txBody>
+          <a:bodyPr rtlCol="0" anchor="ctr"/>
+          <a:lstStyle/>
+          <a:p>
+            <a:pPr algn="ctr"/>
+          </a:p>
+        </p:txBody>
+      </p:sp>
+      <p:sp>
+        <p:nvSpPr>
+          <p:cNvPr id="63" name="TextBox 62"/>
+          <p:cNvSpPr txBox="1"/>
+          <p:nvPr/>
+        </p:nvSpPr>
+        <p:spPr>
+          <a:xfrm>
+            <a:off x="640080" y="3291840"/>
+            <a:ext cx="10789920" cy="274320"/>
+          </a:xfrm>
+          <a:prstGeom prst="rect">
+            <a:avLst/>
+          </a:prstGeom>
+          <a:noFill/>
+        </p:spPr>
+        <p:txBody>
+          <a:bodyPr wrap="square">
+            <a:spAutoFit/>
+          </a:bodyPr>
+          <a:lstStyle/>
+          <a:p>
+            <a:pPr algn="l"/>
+            <a:r>
+              <a:rPr sz="1600" b="1" i="0">
+                <a:solidFill>
+                  <a:srgbClr val="1B3A6B"/>
+                </a:solidFill>
+              </a:rPr>
+              <a:t>Q2: CRM Status Freshness — Real-time or Batch?</a:t>
+            </a:r>
+          </a:p>
+        </p:txBody>
+      </p:sp>
+      <p:sp>
+        <p:nvSpPr>
+          <p:cNvPr id="64" name="TextBox 63"/>
+          <p:cNvSpPr txBox="1"/>
+          <p:nvPr/>
+        </p:nvSpPr>
+        <p:spPr>
+          <a:xfrm>
+            <a:off x="640080" y="3657600"/>
+            <a:ext cx="10789920" cy="457200"/>
+          </a:xfrm>
+          <a:prstGeom prst="rect">
+            <a:avLst/>
+          </a:prstGeom>
+          <a:noFill/>
+        </p:spPr>
+        <p:txBody>
+          <a:bodyPr wrap="square">
+            <a:spAutoFit/>
+          </a:bodyPr>
+          <a:lstStyle/>
+          <a:p>
+            <a:pPr algn="l"/>
+            <a:r>
+              <a:rPr sz="1300" b="0" i="0">
+                <a:solidFill>
+                  <a:srgbClr val="2D2D2D"/>
+                </a:solidFill>
+              </a:rPr>
+              <a:t>When a driver scans a package, how long before that status appears in Salesforce? Immediate webhook, 5-30 min polling, or end-of-shift batch?</a:t>
+            </a:r>
+          </a:p>
+        </p:txBody>
+      </p:sp>
+      <p:sp>
+        <p:nvSpPr>
+          <p:cNvPr id="65" name="TextBox 64"/>
+          <p:cNvSpPr txBox="1"/>
+          <p:nvPr/>
+        </p:nvSpPr>
+        <p:spPr>
+          <a:xfrm>
+            <a:off x="640080" y="4023360"/>
+            <a:ext cx="10789920" cy="365760"/>
+          </a:xfrm>
+          <a:prstGeom prst="rect">
+            <a:avLst/>
+          </a:prstGeom>
+          <a:noFill/>
+        </p:spPr>
+        <p:txBody>
+          <a:bodyPr wrap="square">
+            <a:spAutoFit/>
+          </a:bodyPr>
+          <a:lstStyle/>
+          <a:p>
+            <a:pPr algn="l"/>
+            <a:r>
+              <a:rPr sz="1200" b="0" i="1">
+                <a:solidFill>
+                  <a:srgbClr val="BF352A"/>
+                </a:solidFill>
+              </a:rPr>
+              <a:t>Impact: If end-of-day batch, 'out-for-delivery' status is unreliable. ETA logic breaks, requires full redesign.</a:t>
+            </a:r>
+          </a:p>
+        </p:txBody>
+      </p:sp>
+      <p:sp>
+        <p:nvSpPr>
+          <p:cNvPr id="66" name="Rectangle 65"/>
+          <p:cNvSpPr/>
+          <p:nvPr/>
+        </p:nvSpPr>
+        <p:spPr>
+          <a:xfrm>
+            <a:off x="457200" y="4572000"/>
+            <a:ext cx="11247120" cy="1280160"/>
+          </a:xfrm>
+          <a:prstGeom prst="rect">
+            <a:avLst/>
+          </a:prstGeom>
+          <a:solidFill>
+            <a:srgbClr val="F2F4F7"/>
+          </a:solidFill>
+          <a:ln>
+            <a:noFill/>
+          </a:ln>
+        </p:spPr>
+        <p:style>
+          <a:lnRef idx="1">
+            <a:schemeClr val="accent1"/>
+          </a:lnRef>
+          <a:fillRef idx="3">
+            <a:schemeClr val="accent1"/>
+          </a:fillRef>
+          <a:effectRef idx="2">
+            <a:schemeClr val="accent1"/>
+          </a:effectRef>
+          <a:fontRef idx="minor">
+            <a:schemeClr val="lt1"/>
+          </a:fontRef>
+        </p:style>
+        <p:txBody>
+          <a:bodyPr rtlCol="0" anchor="ctr"/>
+          <a:lstStyle/>
+          <a:p>
+            <a:pPr algn="ctr"/>
+          </a:p>
+        </p:txBody>
+      </p:sp>
+      <p:sp>
+        <p:nvSpPr>
+          <p:cNvPr id="67" name="TextBox 66"/>
+          <p:cNvSpPr txBox="1"/>
+          <p:nvPr/>
+        </p:nvSpPr>
+        <p:spPr>
+          <a:xfrm>
+            <a:off x="640080" y="4754880"/>
+            <a:ext cx="10789920" cy="274320"/>
+          </a:xfrm>
+          <a:prstGeom prst="rect">
+            <a:avLst/>
+          </a:prstGeom>
+          <a:noFill/>
+        </p:spPr>
+        <p:txBody>
+          <a:bodyPr wrap="square">
+            <a:spAutoFit/>
+          </a:bodyPr>
+          <a:lstStyle/>
+          <a:p>
+            <a:pPr algn="l"/>
+            <a:r>
+              <a:rPr sz="1600" b="1" i="0">
+                <a:solidFill>
+                  <a:srgbClr val="1B3A6B"/>
+                </a:solidFill>
+              </a:rPr>
+              <a:t>Q3: The Sandra Credit Audit Gap — Known Issue or Off-Policy?</a:t>
+            </a:r>
+          </a:p>
+        </p:txBody>
+      </p:sp>
+      <p:sp>
+        <p:nvSpPr>
+          <p:cNvPr id="68" name="TextBox 67"/>
+          <p:cNvSpPr txBox="1"/>
+          <p:nvPr/>
+        </p:nvSpPr>
+        <p:spPr>
+          <a:xfrm>
+            <a:off x="640080" y="5120640"/>
+            <a:ext cx="10789920" cy="457200"/>
+          </a:xfrm>
+          <a:prstGeom prst="rect">
+            <a:avLst/>
+          </a:prstGeom>
+          <a:noFill/>
+        </p:spPr>
+        <p:txBody>
+          <a:bodyPr wrap="square">
+            <a:spAutoFit/>
+          </a:bodyPr>
+          <a:lstStyle/>
+          <a:p>
+            <a:pPr algn="l"/>
+            <a:r>
+              <a:rPr sz="1300" b="0" i="0">
+                <a:solidFill>
+                  <a:srgbClr val="2D2D2D"/>
+                </a:solidFill>
+              </a:rPr>
+              <a:t>The 170 pound Hayes &amp; Sons credit has no audit log entry. Is this a known gap where manual overrides bypass the export, or was it off-policy?</a:t>
+            </a:r>
+          </a:p>
+        </p:txBody>
+      </p:sp>
+      <p:sp>
+        <p:nvSpPr>
+          <p:cNvPr id="69" name="TextBox 68"/>
+          <p:cNvSpPr txBox="1"/>
+          <p:nvPr/>
+        </p:nvSpPr>
+        <p:spPr>
+          <a:xfrm>
+            <a:off x="640080" y="5486400"/>
+            <a:ext cx="10789920" cy="365760"/>
+          </a:xfrm>
+          <a:prstGeom prst="rect">
+            <a:avLst/>
+          </a:prstGeom>
+          <a:noFill/>
+        </p:spPr>
+        <p:txBody>
+          <a:bodyPr wrap="square">
+            <a:spAutoFit/>
+          </a:bodyPr>
+          <a:lstStyle/>
+          <a:p>
+            <a:pPr algn="l"/>
+            <a:r>
+              <a:rPr sz="1200" b="0" i="1">
+                <a:solidFill>
+                  <a:srgbClr val="BF352A"/>
+                </a:solidFill>
+              </a:rPr>
+              <a:t>Impact: If exports are incomplete, Phase 2 billing agent will misidentify resolved disputes. Compliance risk.</a:t>
+            </a:r>
+          </a:p>
+        </p:txBody>
+      </p:sp>
+      <p:sp>
+        <p:nvSpPr>
+          <p:cNvPr id="70" name="TextBox 69"/>
+          <p:cNvSpPr txBox="1"/>
+          <p:nvPr/>
+        </p:nvSpPr>
+        <p:spPr>
+          <a:xfrm>
+            <a:off x="457200" y="6126480"/>
+            <a:ext cx="11247120" cy="274320"/>
+          </a:xfrm>
+          <a:prstGeom prst="rect">
+            <a:avLst/>
+          </a:prstGeom>
+          <a:noFill/>
+        </p:spPr>
+        <p:txBody>
+          <a:bodyPr wrap="square">
+            <a:spAutoFit/>
+          </a:bodyPr>
+          <a:lstStyle/>
+          <a:p>
+            <a:pPr algn="ctr"/>
+            <a:r>
+              <a:rPr sz="1400" b="0" i="0">
+                <a:solidFill>
+                  <a:srgbClr val="2E5FA3"/>
+                </a:solidFill>
+              </a:rPr>
+              <a:t>These questions target assumptions rated LOW confidence - answers change architecture</a:t>
+            </a:r>
+          </a:p>
+        </p:txBody>
+      </p:sp>
+    </p:spTree>
+  </p:cSld>
+  <p:clrMapOvr>
+    <a:masterClrMapping/>
+  </p:clrMapOvr>
+</p:sld>
+</file>
+
+<file path=ppt/slides/slide7.xml><?xml version="1.0" encoding="utf-8"?>
+<p:sld xmlns:a="http://schemas.openxmlformats.org/drawingml/2006/main" xmlns:p="http://schemas.openxmlformats.org/presentationml/2006/main" xmlns:r="http://schemas.openxmlformats.org/officeDocument/2006/relationships">
+  <p:cSld>
+    <p:spTree>
+      <p:nvGrpSpPr>
+        <p:cNvPr id="1" name=""/>
+        <p:cNvGrpSpPr/>
+        <p:nvPr/>
+      </p:nvGrpSpPr>
+      <p:grpSpPr/>
     </p:spTree>
   </p:cSld>
   <p:clrMapOvr>

</xml_diff>